<commit_message>
Rebuild README — visual demo, fraud detection, live app link
</commit_message>
<xml_diff>
--- a/VeriCell_Pitch_Deck.pptx
+++ b/VeriCell_Pitch_Deck.pptx
@@ -4664,7 +4664,7 @@
           </a:solidFill>
           <a:ln w="25400">
             <a:solidFill>
-              <a:srgbClr val="4ADE80"/>
+              <a:srgbClr val="C084FC"/>
             </a:solidFill>
           </a:ln>
         </p:spPr>
@@ -4699,6 +4699,166 @@
         <p:spPr>
           <a:xfrm>
             <a:off x="457200" y="1371600"/>
+            <a:ext cx="109728" cy="804672"/>
+          </a:xfrm>
+          <a:prstGeom prst="rect">
+            <a:avLst/>
+          </a:prstGeom>
+          <a:solidFill>
+            <a:srgbClr val="C084FC"/>
+          </a:solidFill>
+          <a:ln>
+            <a:solidFill>
+              <a:srgbClr val="C084FC"/>
+            </a:solidFill>
+          </a:ln>
+        </p:spPr>
+        <p:style>
+          <a:lnRef idx="1">
+            <a:schemeClr val="accent1"/>
+          </a:lnRef>
+          <a:fillRef idx="3">
+            <a:schemeClr val="accent1"/>
+          </a:fillRef>
+          <a:effectRef idx="2">
+            <a:schemeClr val="accent1"/>
+          </a:effectRef>
+          <a:fontRef idx="minor">
+            <a:schemeClr val="lt1"/>
+          </a:fontRef>
+        </p:style>
+        <p:txBody>
+          <a:bodyPr rtlCol="0" anchor="ctr"/>
+          <a:lstStyle/>
+          <a:p>
+            <a:pPr algn="ctr"/>
+          </a:p>
+        </p:txBody>
+      </p:sp>
+      <p:sp>
+        <p:nvSpPr>
+          <p:cNvPr id="8" name="TextBox 7"/>
+          <p:cNvSpPr txBox="1"/>
+          <p:nvPr/>
+        </p:nvSpPr>
+        <p:spPr>
+          <a:xfrm>
+            <a:off x="731520" y="1426464"/>
+            <a:ext cx="5029200" cy="347472"/>
+          </a:xfrm>
+          <a:prstGeom prst="rect">
+            <a:avLst/>
+          </a:prstGeom>
+          <a:noFill/>
+        </p:spPr>
+        <p:txBody>
+          <a:bodyPr wrap="square">
+            <a:spAutoFit/>
+          </a:bodyPr>
+          <a:lstStyle/>
+          <a:p>
+            <a:pPr algn="l"/>
+            <a:r>
+              <a:rPr sz="1700" b="1" i="0">
+                <a:solidFill>
+                  <a:srgbClr val="C084FC"/>
+                </a:solidFill>
+                <a:latin typeface="Calibri"/>
+              </a:rPr>
+              <a:t>🔬  Physical Sensor Verification — no competitor has this</a:t>
+            </a:r>
+          </a:p>
+        </p:txBody>
+      </p:sp>
+      <p:sp>
+        <p:nvSpPr>
+          <p:cNvPr id="9" name="TextBox 8"/>
+          <p:cNvSpPr txBox="1"/>
+          <p:nvPr/>
+        </p:nvSpPr>
+        <p:spPr>
+          <a:xfrm>
+            <a:off x="5943600" y="1426464"/>
+            <a:ext cx="5669280" cy="694944"/>
+          </a:xfrm>
+          <a:prstGeom prst="rect">
+            <a:avLst/>
+          </a:prstGeom>
+          <a:noFill/>
+        </p:spPr>
+        <p:txBody>
+          <a:bodyPr wrap="square">
+            <a:spAutoFit/>
+          </a:bodyPr>
+          <a:lstStyle/>
+          <a:p>
+            <a:pPr algn="l"/>
+            <a:r>
+              <a:rPr sz="1400" b="0" i="0">
+                <a:solidFill>
+                  <a:srgbClr val="7A92B4"/>
+                </a:solidFill>
+                <a:latin typeface="Calibri"/>
+              </a:rPr>
+              <a:t>Every other platform validates documents. We validate the physical battery. BMS readings vs declared values. Second-life operators can finally trust the SoH.</a:t>
+            </a:r>
+          </a:p>
+        </p:txBody>
+      </p:sp>
+      <p:sp>
+        <p:nvSpPr>
+          <p:cNvPr id="10" name="Rectangle 9"/>
+          <p:cNvSpPr/>
+          <p:nvPr/>
+        </p:nvSpPr>
+        <p:spPr>
+          <a:xfrm>
+            <a:off x="457200" y="2267712"/>
+            <a:ext cx="11274552" cy="804672"/>
+          </a:xfrm>
+          <a:prstGeom prst="rect">
+            <a:avLst/>
+          </a:prstGeom>
+          <a:solidFill>
+            <a:srgbClr val="0D1526"/>
+          </a:solidFill>
+          <a:ln w="25400">
+            <a:solidFill>
+              <a:srgbClr val="4ADE80"/>
+            </a:solidFill>
+          </a:ln>
+        </p:spPr>
+        <p:style>
+          <a:lnRef idx="1">
+            <a:schemeClr val="accent1"/>
+          </a:lnRef>
+          <a:fillRef idx="3">
+            <a:schemeClr val="accent1"/>
+          </a:fillRef>
+          <a:effectRef idx="2">
+            <a:schemeClr val="accent1"/>
+          </a:effectRef>
+          <a:fontRef idx="minor">
+            <a:schemeClr val="lt1"/>
+          </a:fontRef>
+        </p:style>
+        <p:txBody>
+          <a:bodyPr rtlCol="0" anchor="ctr"/>
+          <a:lstStyle/>
+          <a:p>
+            <a:pPr algn="ctr"/>
+          </a:p>
+        </p:txBody>
+      </p:sp>
+      <p:sp>
+        <p:nvSpPr>
+          <p:cNvPr id="11" name="Rectangle 10"/>
+          <p:cNvSpPr/>
+          <p:nvPr/>
+        </p:nvSpPr>
+        <p:spPr>
+          <a:xfrm>
+            <a:off x="457200" y="2267712"/>
             <a:ext cx="109728" cy="804672"/>
           </a:xfrm>
           <a:prstGeom prst="rect">
@@ -4737,13 +4897,13 @@
       </p:sp>
       <p:sp>
         <p:nvSpPr>
-          <p:cNvPr id="8" name="TextBox 7"/>
-          <p:cNvSpPr txBox="1"/>
-          <p:nvPr/>
-        </p:nvSpPr>
-        <p:spPr>
-          <a:xfrm>
-            <a:off x="731520" y="1426464"/>
+          <p:cNvPr id="12" name="TextBox 11"/>
+          <p:cNvSpPr txBox="1"/>
+          <p:nvPr/>
+        </p:nvSpPr>
+        <p:spPr>
+          <a:xfrm>
+            <a:off x="731520" y="2322576"/>
             <a:ext cx="5029200" cy="347472"/>
           </a:xfrm>
           <a:prstGeom prst="rect">
@@ -4772,13 +4932,13 @@
       </p:sp>
       <p:sp>
         <p:nvSpPr>
-          <p:cNvPr id="9" name="TextBox 8"/>
-          <p:cNvSpPr txBox="1"/>
-          <p:nvPr/>
-        </p:nvSpPr>
-        <p:spPr>
-          <a:xfrm>
-            <a:off x="5943600" y="1426464"/>
+          <p:cNvPr id="13" name="TextBox 12"/>
+          <p:cNvSpPr txBox="1"/>
+          <p:nvPr/>
+        </p:nvSpPr>
+        <p:spPr>
+          <a:xfrm>
+            <a:off x="5943600" y="2322576"/>
             <a:ext cx="5669280" cy="694944"/>
           </a:xfrm>
           <a:prstGeom prst="rect">
@@ -4807,13 +4967,13 @@
       </p:sp>
       <p:sp>
         <p:nvSpPr>
-          <p:cNvPr id="10" name="Rectangle 9"/>
+          <p:cNvPr id="14" name="Rectangle 13"/>
           <p:cNvSpPr/>
           <p:nvPr/>
         </p:nvSpPr>
         <p:spPr>
           <a:xfrm>
-            <a:off x="457200" y="2267712"/>
+            <a:off x="457200" y="3163824"/>
             <a:ext cx="11274552" cy="804672"/>
           </a:xfrm>
           <a:prstGeom prst="rect">
@@ -4852,13 +5012,13 @@
       </p:sp>
       <p:sp>
         <p:nvSpPr>
-          <p:cNvPr id="11" name="Rectangle 10"/>
+          <p:cNvPr id="15" name="Rectangle 14"/>
           <p:cNvSpPr/>
           <p:nvPr/>
         </p:nvSpPr>
         <p:spPr>
           <a:xfrm>
-            <a:off x="457200" y="2267712"/>
+            <a:off x="457200" y="3163824"/>
             <a:ext cx="109728" cy="804672"/>
           </a:xfrm>
           <a:prstGeom prst="rect">
@@ -4897,13 +5057,13 @@
       </p:sp>
       <p:sp>
         <p:nvSpPr>
-          <p:cNvPr id="12" name="TextBox 11"/>
-          <p:cNvSpPr txBox="1"/>
-          <p:nvPr/>
-        </p:nvSpPr>
-        <p:spPr>
-          <a:xfrm>
-            <a:off x="731520" y="2322576"/>
+          <p:cNvPr id="16" name="TextBox 15"/>
+          <p:cNvSpPr txBox="1"/>
+          <p:nvPr/>
+        </p:nvSpPr>
+        <p:spPr>
+          <a:xfrm>
+            <a:off x="731520" y="3218688"/>
             <a:ext cx="5029200" cy="347472"/>
           </a:xfrm>
           <a:prstGeom prst="rect">
@@ -4932,13 +5092,13 @@
       </p:sp>
       <p:sp>
         <p:nvSpPr>
-          <p:cNvPr id="13" name="TextBox 12"/>
-          <p:cNvSpPr txBox="1"/>
-          <p:nvPr/>
-        </p:nvSpPr>
-        <p:spPr>
-          <a:xfrm>
-            <a:off x="5943600" y="2322576"/>
+          <p:cNvPr id="17" name="TextBox 16"/>
+          <p:cNvSpPr txBox="1"/>
+          <p:nvPr/>
+        </p:nvSpPr>
+        <p:spPr>
+          <a:xfrm>
+            <a:off x="5943600" y="3218688"/>
             <a:ext cx="5669280" cy="694944"/>
           </a:xfrm>
           <a:prstGeom prst="rect">
@@ -4967,13 +5127,13 @@
       </p:sp>
       <p:sp>
         <p:nvSpPr>
-          <p:cNvPr id="14" name="Rectangle 13"/>
+          <p:cNvPr id="18" name="Rectangle 17"/>
           <p:cNvSpPr/>
           <p:nvPr/>
         </p:nvSpPr>
         <p:spPr>
           <a:xfrm>
-            <a:off x="457200" y="3163824"/>
+            <a:off x="457200" y="4059936"/>
             <a:ext cx="11274552" cy="804672"/>
           </a:xfrm>
           <a:prstGeom prst="rect">
@@ -5012,13 +5172,13 @@
       </p:sp>
       <p:sp>
         <p:nvSpPr>
-          <p:cNvPr id="15" name="Rectangle 14"/>
+          <p:cNvPr id="19" name="Rectangle 18"/>
           <p:cNvSpPr/>
           <p:nvPr/>
         </p:nvSpPr>
         <p:spPr>
           <a:xfrm>
-            <a:off x="457200" y="3163824"/>
+            <a:off x="457200" y="4059936"/>
             <a:ext cx="109728" cy="804672"/>
           </a:xfrm>
           <a:prstGeom prst="rect">
@@ -5057,166 +5217,6 @@
       </p:sp>
       <p:sp>
         <p:nvSpPr>
-          <p:cNvPr id="16" name="TextBox 15"/>
-          <p:cNvSpPr txBox="1"/>
-          <p:nvPr/>
-        </p:nvSpPr>
-        <p:spPr>
-          <a:xfrm>
-            <a:off x="731520" y="3218688"/>
-            <a:ext cx="5029200" cy="347472"/>
-          </a:xfrm>
-          <a:prstGeom prst="rect">
-            <a:avLst/>
-          </a:prstGeom>
-          <a:noFill/>
-        </p:spPr>
-        <p:txBody>
-          <a:bodyPr wrap="square">
-            <a:spAutoFit/>
-          </a:bodyPr>
-          <a:lstStyle/>
-          <a:p>
-            <a:pPr algn="l"/>
-            <a:r>
-              <a:rPr sz="1700" b="1" i="0">
-                <a:solidFill>
-                  <a:srgbClr val="FBBF24"/>
-                </a:solidFill>
-                <a:latin typeface="Calibri"/>
-              </a:rPr>
-              <a:t>Math-enforced trust scoring</a:t>
-            </a:r>
-          </a:p>
-        </p:txBody>
-      </p:sp>
-      <p:sp>
-        <p:nvSpPr>
-          <p:cNvPr id="17" name="TextBox 16"/>
-          <p:cNvSpPr txBox="1"/>
-          <p:nvPr/>
-        </p:nvSpPr>
-        <p:spPr>
-          <a:xfrm>
-            <a:off x="5943600" y="3218688"/>
-            <a:ext cx="5669280" cy="694944"/>
-          </a:xfrm>
-          <a:prstGeom prst="rect">
-            <a:avLst/>
-          </a:prstGeom>
-          <a:noFill/>
-        </p:spPr>
-        <p:txBody>
-          <a:bodyPr wrap="square">
-            <a:spAutoFit/>
-          </a:bodyPr>
-          <a:lstStyle/>
-          <a:p>
-            <a:pPr algn="l"/>
-            <a:r>
-              <a:rPr sz="1400" b="0" i="0">
-                <a:solidFill>
-                  <a:srgbClr val="7A92B4"/>
-                </a:solidFill>
-                <a:latin typeface="Calibri"/>
-              </a:rPr>
-              <a:t>Score formula cannot be gamed. 0% verified data = max score of 50/100. Period.</a:t>
-            </a:r>
-          </a:p>
-        </p:txBody>
-      </p:sp>
-      <p:sp>
-        <p:nvSpPr>
-          <p:cNvPr id="18" name="Rectangle 17"/>
-          <p:cNvSpPr/>
-          <p:nvPr/>
-        </p:nvSpPr>
-        <p:spPr>
-          <a:xfrm>
-            <a:off x="457200" y="4059936"/>
-            <a:ext cx="11274552" cy="804672"/>
-          </a:xfrm>
-          <a:prstGeom prst="rect">
-            <a:avLst/>
-          </a:prstGeom>
-          <a:solidFill>
-            <a:srgbClr val="0D1526"/>
-          </a:solidFill>
-          <a:ln w="25400">
-            <a:solidFill>
-              <a:srgbClr val="C084FC"/>
-            </a:solidFill>
-          </a:ln>
-        </p:spPr>
-        <p:style>
-          <a:lnRef idx="1">
-            <a:schemeClr val="accent1"/>
-          </a:lnRef>
-          <a:fillRef idx="3">
-            <a:schemeClr val="accent1"/>
-          </a:fillRef>
-          <a:effectRef idx="2">
-            <a:schemeClr val="accent1"/>
-          </a:effectRef>
-          <a:fontRef idx="minor">
-            <a:schemeClr val="lt1"/>
-          </a:fontRef>
-        </p:style>
-        <p:txBody>
-          <a:bodyPr rtlCol="0" anchor="ctr"/>
-          <a:lstStyle/>
-          <a:p>
-            <a:pPr algn="ctr"/>
-          </a:p>
-        </p:txBody>
-      </p:sp>
-      <p:sp>
-        <p:nvSpPr>
-          <p:cNvPr id="19" name="Rectangle 18"/>
-          <p:cNvSpPr/>
-          <p:nvPr/>
-        </p:nvSpPr>
-        <p:spPr>
-          <a:xfrm>
-            <a:off x="457200" y="4059936"/>
-            <a:ext cx="109728" cy="804672"/>
-          </a:xfrm>
-          <a:prstGeom prst="rect">
-            <a:avLst/>
-          </a:prstGeom>
-          <a:solidFill>
-            <a:srgbClr val="C084FC"/>
-          </a:solidFill>
-          <a:ln>
-            <a:solidFill>
-              <a:srgbClr val="C084FC"/>
-            </a:solidFill>
-          </a:ln>
-        </p:spPr>
-        <p:style>
-          <a:lnRef idx="1">
-            <a:schemeClr val="accent1"/>
-          </a:lnRef>
-          <a:fillRef idx="3">
-            <a:schemeClr val="accent1"/>
-          </a:fillRef>
-          <a:effectRef idx="2">
-            <a:schemeClr val="accent1"/>
-          </a:effectRef>
-          <a:fontRef idx="minor">
-            <a:schemeClr val="lt1"/>
-          </a:fontRef>
-        </p:style>
-        <p:txBody>
-          <a:bodyPr rtlCol="0" anchor="ctr"/>
-          <a:lstStyle/>
-          <a:p>
-            <a:pPr algn="ctr"/>
-          </a:p>
-        </p:txBody>
-      </p:sp>
-      <p:sp>
-        <p:nvSpPr>
           <p:cNvPr id="20" name="TextBox 19"/>
           <p:cNvSpPr txBox="1"/>
           <p:nvPr/>
@@ -5241,11 +5241,11 @@
             <a:r>
               <a:rPr sz="1700" b="1" i="0">
                 <a:solidFill>
-                  <a:srgbClr val="C084FC"/>
-                </a:solidFill>
-                <a:latin typeface="Calibri"/>
-              </a:rPr>
-              <a:t>Private trust layer — no regulatory approval needed</a:t>
+                  <a:srgbClr val="FBBF24"/>
+                </a:solidFill>
+                <a:latin typeface="Calibri"/>
+              </a:rPr>
+              <a:t>Math-enforced trust scoring</a:t>
             </a:r>
           </a:p>
         </p:txBody>
@@ -5280,7 +5280,7 @@
                 </a:solidFill>
                 <a:latin typeface="Calibri"/>
               </a:rPr>
-              <a:t>Like AVILOO for used EVs. We issue the badge. Buyers pay more for certified batteries.</a:t>
+              <a:t>Score formula cannot be gamed. 0% verified data = max score of 50/100. Period.</a:t>
             </a:r>
           </a:p>
         </p:txBody>
@@ -5405,7 +5405,7 @@
                 </a:solidFill>
                 <a:latin typeface="Calibri"/>
               </a:rPr>
-              <a:t>Right timing — mandatory from 2027</a:t>
+              <a:t>Private trust layer — like AVILOO for used EVs</a:t>
             </a:r>
           </a:p>
         </p:txBody>
@@ -5440,7 +5440,7 @@
                 </a:solidFill>
                 <a:latin typeface="Calibri"/>
               </a:rPr>
-              <a:t>EU DPP is law. Every battery maker needs validation. We build the layer now.</a:t>
+              <a:t>No regulatory approval needed to operate. We issue the badge. Buyers pay more for certified batteries.</a:t>
             </a:r>
           </a:p>
         </p:txBody>
@@ -7847,8 +7847,8 @@
         </p:nvSpPr>
         <p:spPr>
           <a:xfrm>
-            <a:off x="731520" y="1097280"/>
-            <a:ext cx="10698480" cy="914400"/>
+            <a:off x="731520" y="822960"/>
+            <a:ext cx="10698480" cy="685800"/>
           </a:xfrm>
           <a:prstGeom prst="rect">
             <a:avLst/>
@@ -7863,13 +7863,13 @@
           <a:p>
             <a:pPr algn="ctr"/>
             <a:r>
-              <a:rPr sz="3800" b="0" i="0">
+              <a:rPr sz="3600" b="0" i="0">
                 <a:solidFill>
                   <a:srgbClr val="7A92B4"/>
                 </a:solidFill>
                 <a:latin typeface="Calibri"/>
               </a:rPr>
-              <a:t>The data already exists.</a:t>
+              <a:t>Manufacturers claim.</a:t>
             </a:r>
           </a:p>
         </p:txBody>
@@ -7882,8 +7882,8 @@
         </p:nvSpPr>
         <p:spPr>
           <a:xfrm>
-            <a:off x="731520" y="2011680"/>
-            <a:ext cx="10698480" cy="914400"/>
+            <a:off x="731520" y="1554480"/>
+            <a:ext cx="10698480" cy="685800"/>
           </a:xfrm>
           <a:prstGeom prst="rect">
             <a:avLst/>
@@ -7898,13 +7898,13 @@
           <a:p>
             <a:pPr algn="ctr"/>
             <a:r>
-              <a:rPr sz="3800" b="0" i="0">
+              <a:rPr sz="3600" b="0" i="0">
                 <a:solidFill>
                   <a:srgbClr val="7A92B4"/>
                 </a:solidFill>
                 <a:latin typeface="Calibri"/>
               </a:rPr>
-              <a:t>The regulation is already written.</a:t>
+              <a:t>Regulators demand proof.</a:t>
             </a:r>
           </a:p>
         </p:txBody>
@@ -7917,8 +7917,8 @@
         </p:nvSpPr>
         <p:spPr>
           <a:xfrm>
-            <a:off x="731520" y="2926080"/>
-            <a:ext cx="10698480" cy="914400"/>
+            <a:off x="731520" y="2286000"/>
+            <a:ext cx="10698480" cy="685800"/>
           </a:xfrm>
           <a:prstGeom prst="rect">
             <a:avLst/>
@@ -7933,26 +7933,61 @@
           <a:p>
             <a:pPr algn="ctr"/>
             <a:r>
-              <a:rPr sz="3800" b="0" i="0">
-                <a:solidFill>
-                  <a:srgbClr val="E8F0FF"/>
-                </a:solidFill>
-                <a:latin typeface="Calibri"/>
-              </a:rPr>
-              <a:t>The problem costs €3 billion a year.</a:t>
-            </a:r>
-          </a:p>
-        </p:txBody>
-      </p:sp>
-      <p:sp>
-        <p:nvSpPr>
-          <p:cNvPr id="6" name="Rectangle 5"/>
+              <a:rPr sz="3600" b="0" i="0">
+                <a:solidFill>
+                  <a:srgbClr val="7A92B4"/>
+                </a:solidFill>
+                <a:latin typeface="Calibri"/>
+              </a:rPr>
+              <a:t>Buyers need certainty.</a:t>
+            </a:r>
+          </a:p>
+        </p:txBody>
+      </p:sp>
+      <p:sp>
+        <p:nvSpPr>
+          <p:cNvPr id="6" name="TextBox 5"/>
+          <p:cNvSpPr txBox="1"/>
+          <p:nvPr/>
+        </p:nvSpPr>
+        <p:spPr>
+          <a:xfrm>
+            <a:off x="457200" y="3154680"/>
+            <a:ext cx="11247120" cy="868680"/>
+          </a:xfrm>
+          <a:prstGeom prst="rect">
+            <a:avLst/>
+          </a:prstGeom>
+          <a:noFill/>
+        </p:spPr>
+        <p:txBody>
+          <a:bodyPr wrap="square">
+            <a:spAutoFit/>
+          </a:bodyPr>
+          <a:lstStyle/>
+          <a:p>
+            <a:pPr algn="ctr"/>
+            <a:r>
+              <a:rPr sz="4000" b="1" i="0">
+                <a:solidFill>
+                  <a:srgbClr val="4ADE80"/>
+                </a:solidFill>
+                <a:latin typeface="Calibri"/>
+              </a:rPr>
+              <a:t>We provide it — from algorithm to physical sensor.</a:t>
+            </a:r>
+          </a:p>
+        </p:txBody>
+      </p:sp>
+      <p:sp>
+        <p:nvSpPr>
+          <p:cNvPr id="7" name="Rectangle 6"/>
           <p:cNvSpPr/>
           <p:nvPr/>
         </p:nvSpPr>
         <p:spPr>
           <a:xfrm>
-            <a:off x="457200" y="3977639"/>
+            <a:off x="457200" y="4206240"/>
             <a:ext cx="11274552" cy="12700"/>
           </a:xfrm>
           <a:prstGeom prst="rect">
@@ -7989,14 +8024,14 @@
       </p:sp>
       <p:sp>
         <p:nvSpPr>
-          <p:cNvPr id="7" name="TextBox 6"/>
-          <p:cNvSpPr txBox="1"/>
-          <p:nvPr/>
-        </p:nvSpPr>
-        <p:spPr>
-          <a:xfrm>
-            <a:off x="731520" y="4206240"/>
-            <a:ext cx="10698480" cy="914400"/>
+          <p:cNvPr id="8" name="TextBox 7"/>
+          <p:cNvSpPr txBox="1"/>
+          <p:nvPr/>
+        </p:nvSpPr>
+        <p:spPr>
+          <a:xfrm>
+            <a:off x="731520" y="4434840"/>
+            <a:ext cx="10698480" cy="777240"/>
           </a:xfrm>
           <a:prstGeom prst="rect">
             <a:avLst/>
@@ -8011,9 +8046,9 @@
           <a:p>
             <a:pPr algn="ctr"/>
             <a:r>
-              <a:rPr sz="4200" b="1" i="0">
-                <a:solidFill>
-                  <a:srgbClr val="4ADE80"/>
+              <a:rPr sz="3200" b="1" i="0">
+                <a:solidFill>
+                  <a:srgbClr val="E8F0FF"/>
                 </a:solidFill>
                 <a:latin typeface="Calibri"/>
               </a:rPr>
@@ -8024,14 +8059,14 @@
       </p:sp>
       <p:sp>
         <p:nvSpPr>
-          <p:cNvPr id="8" name="TextBox 7"/>
-          <p:cNvSpPr txBox="1"/>
-          <p:nvPr/>
-        </p:nvSpPr>
-        <p:spPr>
-          <a:xfrm>
-            <a:off x="731520" y="5852160"/>
-            <a:ext cx="10698480" cy="640080"/>
+          <p:cNvPr id="9" name="TextBox 8"/>
+          <p:cNvSpPr txBox="1"/>
+          <p:nvPr/>
+        </p:nvSpPr>
+        <p:spPr>
+          <a:xfrm>
+            <a:off x="731520" y="5989320"/>
+            <a:ext cx="10698480" cy="548640"/>
           </a:xfrm>
           <a:prstGeom prst="rect">
             <a:avLst/>
@@ -8046,13 +8081,13 @@
           <a:p>
             <a:pPr algn="ctr"/>
             <a:r>
-              <a:rPr sz="1800" b="0" i="0">
+              <a:rPr sz="1700" b="0" i="0">
                 <a:solidFill>
                   <a:srgbClr val="7A92B4"/>
                 </a:solidFill>
                 <a:latin typeface="Calibri"/>
               </a:rPr>
-              <a:t>TrustLayer VeriCell  —  Trust the battery. Trust the data.</a:t>
+              <a:t>TrustLayer VeriCell  —  Trust the battery. Not just the paperwork.</a:t>
             </a:r>
           </a:p>
         </p:txBody>
@@ -10822,8 +10857,8 @@
         </p:nvSpPr>
         <p:spPr>
           <a:xfrm>
-            <a:off x="640080" y="3063240"/>
-            <a:ext cx="3383280" cy="2560320"/>
+            <a:off x="384048" y="3063240"/>
+            <a:ext cx="2633472" cy="2560320"/>
           </a:xfrm>
           <a:prstGeom prst="rect">
             <a:avLst/>
@@ -10867,8 +10902,8 @@
         </p:nvSpPr>
         <p:spPr>
           <a:xfrm>
-            <a:off x="640080" y="3337560"/>
-            <a:ext cx="3383280" cy="731520"/>
+            <a:off x="384048" y="3337560"/>
+            <a:ext cx="2633472" cy="731520"/>
           </a:xfrm>
           <a:prstGeom prst="rect">
             <a:avLst/>
@@ -10883,7 +10918,7 @@
           <a:p>
             <a:pPr algn="ctr"/>
             <a:r>
-              <a:rPr sz="3800" b="0" i="0">
+              <a:rPr sz="3400" b="0" i="0">
                 <a:solidFill>
                   <a:srgbClr val="E8F0FF"/>
                 </a:solidFill>
@@ -10902,8 +10937,8 @@
         </p:nvSpPr>
         <p:spPr>
           <a:xfrm>
-            <a:off x="640080" y="4114800"/>
-            <a:ext cx="3383280" cy="548640"/>
+            <a:off x="384048" y="4114800"/>
+            <a:ext cx="2633472" cy="548640"/>
           </a:xfrm>
           <a:prstGeom prst="rect">
             <a:avLst/>
@@ -10918,7 +10953,7 @@
           <a:p>
             <a:pPr algn="ctr"/>
             <a:r>
-              <a:rPr sz="2200" b="1" i="0">
+              <a:rPr sz="1800" b="1" i="0">
                 <a:solidFill>
                   <a:srgbClr val="4ADE80"/>
                 </a:solidFill>
@@ -10937,8 +10972,8 @@
         </p:nvSpPr>
         <p:spPr>
           <a:xfrm>
-            <a:off x="640080" y="4663440"/>
-            <a:ext cx="3383280" cy="640080"/>
+            <a:off x="384048" y="4663440"/>
+            <a:ext cx="2633472" cy="640080"/>
           </a:xfrm>
           <a:prstGeom prst="rect">
             <a:avLst/>
@@ -10953,7 +10988,7 @@
           <a:p>
             <a:pPr algn="ctr"/>
             <a:r>
-              <a:rPr sz="1600" b="0" i="0">
+              <a:rPr sz="1400" b="0" i="0">
                 <a:solidFill>
                   <a:srgbClr val="7A92B4"/>
                 </a:solidFill>
@@ -10972,8 +11007,8 @@
         </p:nvSpPr>
         <p:spPr>
           <a:xfrm>
-            <a:off x="4270248" y="3063240"/>
-            <a:ext cx="3383280" cy="2560320"/>
+            <a:off x="3209544" y="3063240"/>
+            <a:ext cx="2633472" cy="2560320"/>
           </a:xfrm>
           <a:prstGeom prst="rect">
             <a:avLst/>
@@ -11017,8 +11052,8 @@
         </p:nvSpPr>
         <p:spPr>
           <a:xfrm>
-            <a:off x="4270248" y="3337560"/>
-            <a:ext cx="3383280" cy="731520"/>
+            <a:off x="3209544" y="3337560"/>
+            <a:ext cx="2633472" cy="731520"/>
           </a:xfrm>
           <a:prstGeom prst="rect">
             <a:avLst/>
@@ -11033,7 +11068,7 @@
           <a:p>
             <a:pPr algn="ctr"/>
             <a:r>
-              <a:rPr sz="3800" b="0" i="0">
+              <a:rPr sz="3400" b="0" i="0">
                 <a:solidFill>
                   <a:srgbClr val="E8F0FF"/>
                 </a:solidFill>
@@ -11052,8 +11087,8 @@
         </p:nvSpPr>
         <p:spPr>
           <a:xfrm>
-            <a:off x="4270248" y="4114800"/>
-            <a:ext cx="3383280" cy="548640"/>
+            <a:off x="3209544" y="4114800"/>
+            <a:ext cx="2633472" cy="548640"/>
           </a:xfrm>
           <a:prstGeom prst="rect">
             <a:avLst/>
@@ -11068,7 +11103,7 @@
           <a:p>
             <a:pPr algn="ctr"/>
             <a:r>
-              <a:rPr sz="2200" b="1" i="0">
+              <a:rPr sz="1800" b="1" i="0">
                 <a:solidFill>
                   <a:srgbClr val="FBBF24"/>
                 </a:solidFill>
@@ -11087,8 +11122,8 @@
         </p:nvSpPr>
         <p:spPr>
           <a:xfrm>
-            <a:off x="4270248" y="4663440"/>
-            <a:ext cx="3383280" cy="640080"/>
+            <a:off x="3209544" y="4663440"/>
+            <a:ext cx="2633472" cy="640080"/>
           </a:xfrm>
           <a:prstGeom prst="rect">
             <a:avLst/>
@@ -11103,7 +11138,7 @@
           <a:p>
             <a:pPr algn="ctr"/>
             <a:r>
-              <a:rPr sz="1600" b="0" i="0">
+              <a:rPr sz="1400" b="0" i="0">
                 <a:solidFill>
                   <a:srgbClr val="7A92B4"/>
                 </a:solidFill>
@@ -11122,8 +11157,8 @@
         </p:nvSpPr>
         <p:spPr>
           <a:xfrm>
-            <a:off x="7900416" y="3063240"/>
-            <a:ext cx="3383280" cy="2560320"/>
+            <a:off x="6035040" y="3063240"/>
+            <a:ext cx="2633472" cy="2560320"/>
           </a:xfrm>
           <a:prstGeom prst="rect">
             <a:avLst/>
@@ -11167,8 +11202,8 @@
         </p:nvSpPr>
         <p:spPr>
           <a:xfrm>
-            <a:off x="7900416" y="3337560"/>
-            <a:ext cx="3383280" cy="731520"/>
+            <a:off x="6035040" y="3337560"/>
+            <a:ext cx="2633472" cy="731520"/>
           </a:xfrm>
           <a:prstGeom prst="rect">
             <a:avLst/>
@@ -11183,7 +11218,7 @@
           <a:p>
             <a:pPr algn="ctr"/>
             <a:r>
-              <a:rPr sz="3800" b="0" i="0">
+              <a:rPr sz="3400" b="0" i="0">
                 <a:solidFill>
                   <a:srgbClr val="E8F0FF"/>
                 </a:solidFill>
@@ -11202,8 +11237,8 @@
         </p:nvSpPr>
         <p:spPr>
           <a:xfrm>
-            <a:off x="7900416" y="4114800"/>
-            <a:ext cx="3383280" cy="548640"/>
+            <a:off x="6035040" y="4114800"/>
+            <a:ext cx="2633472" cy="548640"/>
           </a:xfrm>
           <a:prstGeom prst="rect">
             <a:avLst/>
@@ -11218,7 +11253,7 @@
           <a:p>
             <a:pPr algn="ctr"/>
             <a:r>
-              <a:rPr sz="2200" b="1" i="0">
+              <a:rPr sz="1800" b="1" i="0">
                 <a:solidFill>
                   <a:srgbClr val="60A5FA"/>
                 </a:solidFill>
@@ -11237,8 +11272,8 @@
         </p:nvSpPr>
         <p:spPr>
           <a:xfrm>
-            <a:off x="7900416" y="4663440"/>
-            <a:ext cx="3383280" cy="640080"/>
+            <a:off x="6035040" y="4663440"/>
+            <a:ext cx="2633472" cy="640080"/>
           </a:xfrm>
           <a:prstGeom prst="rect">
             <a:avLst/>
@@ -11253,13 +11288,163 @@
           <a:p>
             <a:pPr algn="ctr"/>
             <a:r>
-              <a:rPr sz="1600" b="0" i="0">
+              <a:rPr sz="1400" b="0" i="0">
                 <a:solidFill>
                   <a:srgbClr val="7A92B4"/>
                 </a:solidFill>
                 <a:latin typeface="Calibri"/>
               </a:rPr>
               <a:t>Live sync to procurement</a:t>
+            </a:r>
+          </a:p>
+        </p:txBody>
+      </p:sp>
+      <p:sp>
+        <p:nvSpPr>
+          <p:cNvPr id="19" name="Rectangle 18"/>
+          <p:cNvSpPr/>
+          <p:nvPr/>
+        </p:nvSpPr>
+        <p:spPr>
+          <a:xfrm>
+            <a:off x="8860536" y="3063240"/>
+            <a:ext cx="2633472" cy="2560320"/>
+          </a:xfrm>
+          <a:prstGeom prst="rect">
+            <a:avLst/>
+          </a:prstGeom>
+          <a:solidFill>
+            <a:srgbClr val="0D1526"/>
+          </a:solidFill>
+          <a:ln w="31750">
+            <a:solidFill>
+              <a:srgbClr val="C084FC"/>
+            </a:solidFill>
+          </a:ln>
+        </p:spPr>
+        <p:style>
+          <a:lnRef idx="1">
+            <a:schemeClr val="accent1"/>
+          </a:lnRef>
+          <a:fillRef idx="3">
+            <a:schemeClr val="accent1"/>
+          </a:fillRef>
+          <a:effectRef idx="2">
+            <a:schemeClr val="accent1"/>
+          </a:effectRef>
+          <a:fontRef idx="minor">
+            <a:schemeClr val="lt1"/>
+          </a:fontRef>
+        </p:style>
+        <p:txBody>
+          <a:bodyPr rtlCol="0" anchor="ctr"/>
+          <a:lstStyle/>
+          <a:p>
+            <a:pPr algn="ctr"/>
+          </a:p>
+        </p:txBody>
+      </p:sp>
+      <p:sp>
+        <p:nvSpPr>
+          <p:cNvPr id="20" name="TextBox 19"/>
+          <p:cNvSpPr txBox="1"/>
+          <p:nvPr/>
+        </p:nvSpPr>
+        <p:spPr>
+          <a:xfrm>
+            <a:off x="8860536" y="3337560"/>
+            <a:ext cx="2633472" cy="731520"/>
+          </a:xfrm>
+          <a:prstGeom prst="rect">
+            <a:avLst/>
+          </a:prstGeom>
+          <a:noFill/>
+        </p:spPr>
+        <p:txBody>
+          <a:bodyPr wrap="square">
+            <a:spAutoFit/>
+          </a:bodyPr>
+          <a:lstStyle/>
+          <a:p>
+            <a:pPr algn="ctr"/>
+            <a:r>
+              <a:rPr sz="3400" b="0" i="0">
+                <a:solidFill>
+                  <a:srgbClr val="E8F0FF"/>
+                </a:solidFill>
+                <a:latin typeface="Calibri"/>
+              </a:rPr>
+              <a:t>🔬</a:t>
+            </a:r>
+          </a:p>
+        </p:txBody>
+      </p:sp>
+      <p:sp>
+        <p:nvSpPr>
+          <p:cNvPr id="21" name="TextBox 20"/>
+          <p:cNvSpPr txBox="1"/>
+          <p:nvPr/>
+        </p:nvSpPr>
+        <p:spPr>
+          <a:xfrm>
+            <a:off x="8860536" y="4114800"/>
+            <a:ext cx="2633472" cy="548640"/>
+          </a:xfrm>
+          <a:prstGeom prst="rect">
+            <a:avLst/>
+          </a:prstGeom>
+          <a:noFill/>
+        </p:spPr>
+        <p:txBody>
+          <a:bodyPr wrap="square">
+            <a:spAutoFit/>
+          </a:bodyPr>
+          <a:lstStyle/>
+          <a:p>
+            <a:pPr algn="ctr"/>
+            <a:r>
+              <a:rPr sz="1800" b="1" i="0">
+                <a:solidFill>
+                  <a:srgbClr val="C084FC"/>
+                </a:solidFill>
+                <a:latin typeface="Calibri"/>
+              </a:rPr>
+              <a:t>Level 2 Badge</a:t>
+            </a:r>
+          </a:p>
+        </p:txBody>
+      </p:sp>
+      <p:sp>
+        <p:nvSpPr>
+          <p:cNvPr id="22" name="TextBox 21"/>
+          <p:cNvSpPr txBox="1"/>
+          <p:nvPr/>
+        </p:nvSpPr>
+        <p:spPr>
+          <a:xfrm>
+            <a:off x="8860536" y="4663440"/>
+            <a:ext cx="2633472" cy="640080"/>
+          </a:xfrm>
+          <a:prstGeom prst="rect">
+            <a:avLst/>
+          </a:prstGeom>
+          <a:noFill/>
+        </p:spPr>
+        <p:txBody>
+          <a:bodyPr wrap="square">
+            <a:spAutoFit/>
+          </a:bodyPr>
+          <a:lstStyle/>
+          <a:p>
+            <a:pPr algn="ctr"/>
+            <a:r>
+              <a:rPr sz="1400" b="0" i="0">
+                <a:solidFill>
+                  <a:srgbClr val="7A92B4"/>
+                </a:solidFill>
+                <a:latin typeface="Calibri"/>
+              </a:rPr>
+              <a:t>Physical Sensor Verified</a:t>
             </a:r>
           </a:p>
         </p:txBody>
@@ -11838,7 +12023,7 @@
                 </a:solidFill>
                 <a:latin typeface="Calibri"/>
               </a:rPr>
-              <a:t>4 compliance years</a:t>
+              <a:t>+ Physical sensor</a:t>
             </a:r>
           </a:p>
         </p:txBody>
@@ -11988,7 +12173,7 @@
                 </a:solidFill>
                 <a:latin typeface="Calibri"/>
               </a:rPr>
-              <a:t>Trust Score + Badge</a:t>
+              <a:t>Trust Score + L2 Badge</a:t>
             </a:r>
           </a:p>
         </p:txBody>
@@ -14003,7 +14188,7 @@
           </a:solidFill>
           <a:ln w="25400">
             <a:solidFill>
-              <a:srgbClr val="4ADE80"/>
+              <a:srgbClr val="C084FC"/>
             </a:solidFill>
           </a:ln>
         </p:spPr>
@@ -14059,7 +14244,7 @@
                 </a:solidFill>
                 <a:latin typeface="Calibri"/>
               </a:rPr>
-              <a:t>🔐</a:t>
+              <a:t>🔬</a:t>
             </a:r>
           </a:p>
         </p:txBody>
@@ -14090,11 +14275,11 @@
             <a:r>
               <a:rPr sz="1700" b="1" i="0">
                 <a:solidFill>
-                  <a:srgbClr val="4ADE80"/>
-                </a:solidFill>
-                <a:latin typeface="Calibri"/>
-              </a:rPr>
-              <a:t>Trust Score That Can't Be Gamed</a:t>
+                  <a:srgbClr val="C084FC"/>
+                </a:solidFill>
+                <a:latin typeface="Calibri"/>
+              </a:rPr>
+              <a:t>Level 2 Physical Sensor Verification</a:t>
             </a:r>
           </a:p>
         </p:txBody>
@@ -14129,8 +14314,9 @@
                 </a:solidFill>
                 <a:latin typeface="Calibri"/>
               </a:rPr>
-              <a:t>Math-enforced ceiling: max trust = (real_data% × 0.5) + 50
-A supplier with 0% verified data cannot score above 50/100.</a:t>
+              <a:t>Software validation = Level 1. Level 2 means declared sensor values
+(voltage, resistance, SoC, temperature) are cross-validated against
+actual BMS readings from the physical battery. No competitor offers this.</a:t>
             </a:r>
           </a:p>
         </p:txBody>
@@ -14154,7 +14340,7 @@
           </a:solidFill>
           <a:ln w="25400">
             <a:solidFill>
-              <a:srgbClr val="60A5FA"/>
+              <a:srgbClr val="4ADE80"/>
             </a:solidFill>
           </a:ln>
         </p:spPr>
@@ -14210,7 +14396,7 @@
                 </a:solidFill>
                 <a:latin typeface="Calibri"/>
               </a:rPr>
-              <a:t>🔍</a:t>
+              <a:t>🔐</a:t>
             </a:r>
           </a:p>
         </p:txBody>
@@ -14241,11 +14427,11 @@
             <a:r>
               <a:rPr sz="1700" b="1" i="0">
                 <a:solidFill>
-                  <a:srgbClr val="60A5FA"/>
-                </a:solidFill>
-                <a:latin typeface="Calibri"/>
-              </a:rPr>
-              <a:t>8 Cross-Field Authenticity Checks</a:t>
+                  <a:srgbClr val="4ADE80"/>
+                </a:solidFill>
+                <a:latin typeface="Calibri"/>
+              </a:rPr>
+              <a:t>Trust Score That Can't Be Gamed</a:t>
             </a:r>
           </a:p>
         </p:txBody>
@@ -14280,8 +14466,8 @@
                 </a:solidFill>
                 <a:latin typeface="Calibri"/>
               </a:rPr>
-              <a:t>V × Ah = kWh  |  Carbon class must match declared value
-Cell count must add up  |  Supply chain verifier must be named.</a:t>
+              <a:t>Math-enforced ceiling: max trust = (real_data% × 0.5) + 50
+A supplier with 0% verified data cannot score above 50/100.</a:t>
             </a:r>
           </a:p>
         </p:txBody>

</xml_diff>